<commit_message>
updated 474 repo name
</commit_message>
<xml_diff>
--- a/d2_presentation.pptx
+++ b/d2_presentation.pptx
@@ -15053,12 +15053,18 @@
             <p:ph sz="half" idx="1"/>
           </p:nvPr>
         </p:nvSpPr>
-        <p:spPr/>
+        <p:spPr>
+          <a:xfrm>
+            <a:off x="457199" y="1604963"/>
+            <a:ext cx="8229599" cy="4525962"/>
+          </a:xfrm>
+        </p:spPr>
         <p:txBody>
           <a:bodyPr/>
           <a:lstStyle/>
           <a:p>
-            <a:pPr>
+            <a:pPr marL="0" indent="0">
+              <a:buNone/>
               <a:defRPr sz="1800"/>
             </a:pPr>
             <a:r>
@@ -15084,13 +15090,12 @@
               <a:t>Repository URL: </a:t>
             </a:r>
             <a:r>
-              <a:rPr dirty="0" err="1"/>
-              <a:t>github.com</a:t>
-            </a:r>
-            <a:r>
-              <a:rPr dirty="0"/>
-              <a:t>/sonicman674/comp474project2026</a:t>
-            </a:r>
+              <a:rPr lang="en-CA" dirty="0">
+                <a:hlinkClick r:id="rId2"/>
+              </a:rPr>
+              <a:t>https://github.com/sonicman674/PC_Hardware_Diagnostic_Expert_System_Stacey_Makary_Oktoro_COMP474</a:t>
+            </a:r>
+            <a:endParaRPr lang="en-CA" dirty="0"/>
           </a:p>
           <a:p>
             <a:pPr lvl="1">
@@ -15100,44 +15105,32 @@
               <a:rPr dirty="0"/>
               <a:t>Canonical project title: PC Hardware Diagnostic Expert System</a:t>
             </a:r>
+            <a:endParaRPr lang="en-CA" dirty="0"/>
+          </a:p>
+          <a:p>
+            <a:pPr marL="0" indent="0">
+              <a:buNone/>
+              <a:defRPr sz="1800"/>
+            </a:pPr>
+            <a:endParaRPr lang="en-CA" dirty="0"/>
+          </a:p>
+          <a:p>
+            <a:pPr marL="0" indent="0">
+              <a:buNone/>
+              <a:defRPr sz="1800"/>
+            </a:pPr>
+            <a:r>
+              <a:rPr lang="en-CA" dirty="0"/>
+              <a:t>Evaluator access notes</a:t>
+            </a:r>
           </a:p>
           <a:p>
             <a:pPr lvl="1">
               <a:defRPr sz="1800"/>
             </a:pPr>
             <a:r>
-              <a:rPr dirty="0"/>
-              <a:t>This repository is the canonical source archive for the deliverables</a:t>
-            </a:r>
-          </a:p>
-        </p:txBody>
-      </p:sp>
-      <p:sp>
-        <p:nvSpPr>
-          <p:cNvPr id="4" name="Content Placeholder 3"/>
-          <p:cNvSpPr>
-            <a:spLocks noGrp="1"/>
-          </p:cNvSpPr>
-          <p:nvPr>
-            <p:ph sz="half" idx="2"/>
-          </p:nvPr>
-        </p:nvSpPr>
-        <p:spPr>
-          <a:xfrm>
-            <a:off x="4648202" y="1604963"/>
-            <a:ext cx="4038600" cy="4525962"/>
-          </a:xfrm>
-        </p:spPr>
-        <p:txBody>
-          <a:bodyPr/>
-          <a:lstStyle/>
-          <a:p>
-            <a:pPr>
-              <a:defRPr sz="1800"/>
-            </a:pPr>
-            <a:r>
-              <a:rPr dirty="0"/>
-              <a:t>Evaluator access notes</a:t>
+              <a:rPr lang="en-CA" dirty="0"/>
+              <a:t>Deliverable source artifacts are stored at the repository root</a:t>
             </a:r>
           </a:p>
           <a:p>
@@ -15145,72 +15138,69 @@
               <a:defRPr sz="1800"/>
             </a:pPr>
             <a:r>
-              <a:rPr dirty="0"/>
-              <a:t>Deliverable source artifacts are stored at the repository root</a:t>
-            </a:r>
+              <a:rPr lang="en-CA" dirty="0"/>
+              <a:t>Key grading files: </a:t>
+            </a:r>
+            <a:r>
+              <a:rPr lang="en-CA" dirty="0" err="1"/>
+              <a:t>facts.txt</a:t>
+            </a:r>
+            <a:r>
+              <a:rPr lang="en-CA" dirty="0"/>
+              <a:t>, </a:t>
+            </a:r>
+            <a:r>
+              <a:rPr lang="en-CA" dirty="0" err="1"/>
+              <a:t>rules.txt</a:t>
+            </a:r>
+            <a:r>
+              <a:rPr lang="en-CA" dirty="0"/>
+              <a:t>, </a:t>
+            </a:r>
+            <a:r>
+              <a:rPr lang="en-CA" dirty="0" err="1"/>
+              <a:t>driver.clp</a:t>
+            </a:r>
+            <a:r>
+              <a:rPr lang="en-CA" dirty="0"/>
+              <a:t>, </a:t>
+            </a:r>
+            <a:r>
+              <a:rPr lang="en-CA" dirty="0" err="1"/>
+              <a:t>design.txt</a:t>
+            </a:r>
+            <a:r>
+              <a:rPr lang="en-CA" dirty="0"/>
+              <a:t>, test-</a:t>
+            </a:r>
+            <a:r>
+              <a:rPr lang="en-CA" dirty="0" err="1"/>
+              <a:t>cases.txt</a:t>
+            </a:r>
+            <a:r>
+              <a:rPr lang="en-CA" dirty="0"/>
+              <a:t>, </a:t>
+            </a:r>
+            <a:r>
+              <a:rPr lang="en-CA" dirty="0" err="1"/>
+              <a:t>README.md</a:t>
+            </a:r>
+            <a:endParaRPr lang="en-CA" dirty="0"/>
           </a:p>
           <a:p>
             <a:pPr lvl="1">
               <a:defRPr sz="1800"/>
             </a:pPr>
             <a:r>
-              <a:rPr dirty="0"/>
-              <a:t>Key grading files: </a:t>
-            </a:r>
-            <a:r>
-              <a:rPr dirty="0" err="1"/>
-              <a:t>facts.txt</a:t>
-            </a:r>
-            <a:r>
-              <a:rPr dirty="0"/>
-              <a:t>, </a:t>
-            </a:r>
-            <a:r>
-              <a:rPr dirty="0" err="1"/>
-              <a:t>rules.txt</a:t>
-            </a:r>
-            <a:r>
-              <a:rPr dirty="0"/>
-              <a:t>, </a:t>
-            </a:r>
-            <a:r>
-              <a:rPr dirty="0" err="1"/>
-              <a:t>driver.clp</a:t>
-            </a:r>
-            <a:r>
-              <a:rPr dirty="0"/>
-              <a:t>, </a:t>
-            </a:r>
-            <a:r>
-              <a:rPr dirty="0" err="1"/>
-              <a:t>design.txt</a:t>
-            </a:r>
-            <a:r>
-              <a:rPr dirty="0"/>
-              <a:t>, test-</a:t>
-            </a:r>
-            <a:r>
-              <a:rPr dirty="0" err="1"/>
-              <a:t>cases.txt</a:t>
-            </a:r>
-            <a:r>
-              <a:rPr dirty="0"/>
-              <a:t>, </a:t>
-            </a:r>
-            <a:r>
-              <a:rPr dirty="0" err="1"/>
-              <a:t>README.md</a:t>
-            </a:r>
-            <a:endParaRPr dirty="0"/>
+              <a:rPr lang="en-CA" dirty="0"/>
+              <a:t>The repository URL should be included in the final submission</a:t>
+            </a:r>
           </a:p>
           <a:p>
             <a:pPr lvl="1">
               <a:defRPr sz="1800"/>
             </a:pPr>
-            <a:r>
-              <a:rPr dirty="0"/>
-              <a:t>The repository URL should be included in the final submission</a:t>
-            </a:r>
+            <a:endParaRPr dirty="0"/>
           </a:p>
         </p:txBody>
       </p:sp>
@@ -22393,13 +22383,18 @@
               <a:t>Repository URL: </a:t>
             </a:r>
             <a:r>
-              <a:rPr dirty="0" err="1"/>
-              <a:t>github.com</a:t>
-            </a:r>
-            <a:r>
-              <a:rPr dirty="0"/>
-              <a:t>/sonicman674/comp474project2026</a:t>
-            </a:r>
+              <a:rPr lang="en-CA" sz="1800" dirty="0">
+                <a:hlinkClick r:id="rId2"/>
+              </a:rPr>
+              <a:t>https://github.com/sonicman674/PC_Hardware_Diagnostic_Expert_System_Stacey_Makary_Oktoro_COMP474</a:t>
+            </a:r>
+            <a:endParaRPr lang="en-CA" sz="1800" dirty="0"/>
+          </a:p>
+          <a:p>
+            <a:pPr lvl="1">
+              <a:defRPr sz="1800"/>
+            </a:pPr>
+            <a:endParaRPr lang="en-CA" sz="1800" dirty="0"/>
           </a:p>
         </p:txBody>
       </p:sp>
@@ -22638,8 +22633,8 @@
         </p:nvSpPr>
         <p:spPr>
           <a:xfrm>
-            <a:off x="159623" y="1796010"/>
-            <a:ext cx="8648046" cy="3785652"/>
+            <a:off x="457199" y="1796010"/>
+            <a:ext cx="8350469" cy="3785652"/>
           </a:xfrm>
           <a:prstGeom prst="rect">
             <a:avLst/>

</xml_diff>